<commit_message>
Expand poster slide to full column with system overview and code stack
https://claude.ai/code/session_01LTwHtLUdysjnDB3Q1XxNkC
</commit_message>
<xml_diff>
--- a/poster_code_section.pptx
+++ b/poster_code_section.pptx
@@ -7,7 +7,7 @@
   <p:sldIdLst>
     <p:sldId id="256" r:id="rId7"/>
   </p:sldIdLst>
-  <p:sldSz cx="4572000" cy="3657600" type="screen4x3"/>
+  <p:sldSz cx="4572000" cy="8357616" type="screen4x3"/>
   <p:notesSz cx="6858000" cy="9144000"/>
   <p:defaultTextStyle>
     <a:defPPr>
@@ -3132,30 +3132,213 @@
           </a:fontRef>
         </p:style>
         <p:txBody>
-          <a:bodyPr rtlCol="0" anchor="ctr" wrap="none"/>
-          <a:lstStyle/>
-          <a:p>
-            <a:pPr algn="ctr"/>
+          <a:bodyPr rtlCol="0" anchor="ctr"/>
+          <a:lstStyle/>
+          <a:p>
+            <a:pPr algn="l"/>
             <a:r>
               <a:rPr sz="1000" b="1">
                 <a:solidFill>
                   <a:srgbClr val="FFFFFF"/>
                 </a:solidFill>
               </a:rPr>
-              <a:t>CODE OVERVIEW</a:t>
-            </a:r>
-          </a:p>
-        </p:txBody>
-      </p:sp>
-      <p:sp>
-        <p:nvSpPr>
-          <p:cNvPr id="3" name="Rectangle 2"/>
+              <a:t>  SYSTEM OVERVIEW</a:t>
+            </a:r>
+          </a:p>
+        </p:txBody>
+      </p:sp>
+      <p:sp>
+        <p:nvSpPr>
+          <p:cNvPr id="3" name="TextBox 2"/>
+          <p:cNvSpPr txBox="1"/>
+          <p:nvPr/>
+        </p:nvSpPr>
+        <p:spPr>
+          <a:xfrm>
+            <a:off x="329184" y="274320"/>
+            <a:ext cx="4078224" cy="1252728"/>
+          </a:xfrm>
+          <a:prstGeom prst="rect">
+            <a:avLst/>
+          </a:prstGeom>
+          <a:noFill/>
+        </p:spPr>
+        <p:txBody>
+          <a:bodyPr wrap="square">
+            <a:spAutoFit/>
+          </a:bodyPr>
+          <a:lstStyle/>
+          <a:p>
+            <a:pPr algn="l"/>
+            <a:r>
+              <a:rPr sz="900">
+                <a:solidFill>
+                  <a:srgbClr val="222222"/>
+                </a:solidFill>
+              </a:rPr>
+              <a:t>•  Backlit light board illuminates tools from below</a:t>
+            </a:r>
+          </a:p>
+          <a:p>
+            <a:pPr algn="l"/>
+            <a:r>
+              <a:rPr sz="900">
+                <a:solidFill>
+                  <a:srgbClr val="222222"/>
+                </a:solidFill>
+              </a:rPr>
+              <a:t>•  Camera mounted overhead captures tool silhouette</a:t>
+            </a:r>
+          </a:p>
+          <a:p>
+            <a:pPr algn="l"/>
+            <a:r>
+              <a:rPr sz="900">
+                <a:solidFill>
+                  <a:srgbClr val="222222"/>
+                </a:solidFill>
+              </a:rPr>
+              <a:t>•  Raspberry Pi runs the full processing pipeline</a:t>
+            </a:r>
+          </a:p>
+          <a:p>
+            <a:pPr algn="l"/>
+            <a:r>
+              <a:rPr sz="900">
+                <a:solidFill>
+                  <a:srgbClr val="222222"/>
+                </a:solidFill>
+              </a:rPr>
+              <a:t>•  ArUco marker provides automatic real-world scale</a:t>
+            </a:r>
+          </a:p>
+          <a:p>
+            <a:pPr algn="l"/>
+            <a:r>
+              <a:rPr sz="900">
+                <a:solidFill>
+                  <a:srgbClr val="222222"/>
+                </a:solidFill>
+              </a:rPr>
+              <a:t>•  Outline expanded for foam insert clearance</a:t>
+            </a:r>
+          </a:p>
+          <a:p>
+            <a:pPr algn="l"/>
+            <a:r>
+              <a:rPr sz="900">
+                <a:solidFill>
+                  <a:srgbClr val="222222"/>
+                </a:solidFill>
+              </a:rPr>
+              <a:t>•  SVG sent to laser cutter → foam shadow board insert</a:t>
+            </a:r>
+          </a:p>
+        </p:txBody>
+      </p:sp>
+      <p:sp>
+        <p:nvSpPr>
+          <p:cNvPr id="4" name="Rectangle 3"/>
           <p:cNvSpPr/>
           <p:nvPr/>
         </p:nvSpPr>
         <p:spPr>
           <a:xfrm>
-            <a:off x="164592" y="347472"/>
+            <a:off x="164592" y="1572768"/>
+            <a:ext cx="4242816" cy="9144"/>
+          </a:xfrm>
+          <a:prstGeom prst="rect">
+            <a:avLst/>
+          </a:prstGeom>
+          <a:solidFill>
+            <a:srgbClr val="DDDDDD"/>
+          </a:solidFill>
+          <a:ln>
+            <a:noFill/>
+          </a:ln>
+        </p:spPr>
+        <p:style>
+          <a:lnRef idx="1">
+            <a:schemeClr val="accent1"/>
+          </a:lnRef>
+          <a:fillRef idx="3">
+            <a:schemeClr val="accent1"/>
+          </a:fillRef>
+          <a:effectRef idx="2">
+            <a:schemeClr val="accent1"/>
+          </a:effectRef>
+          <a:fontRef idx="minor">
+            <a:schemeClr val="lt1"/>
+          </a:fontRef>
+        </p:style>
+        <p:txBody>
+          <a:bodyPr rtlCol="0" anchor="ctr"/>
+          <a:lstStyle/>
+          <a:p>
+            <a:pPr algn="ctr"/>
+          </a:p>
+        </p:txBody>
+      </p:sp>
+      <p:sp>
+        <p:nvSpPr>
+          <p:cNvPr id="5" name="Rectangle 4"/>
+          <p:cNvSpPr/>
+          <p:nvPr/>
+        </p:nvSpPr>
+        <p:spPr>
+          <a:xfrm>
+            <a:off x="0" y="1664208"/>
+            <a:ext cx="4572000" cy="256032"/>
+          </a:xfrm>
+          <a:prstGeom prst="rect">
+            <a:avLst/>
+          </a:prstGeom>
+          <a:solidFill>
+            <a:srgbClr val="1A3A4A"/>
+          </a:solidFill>
+          <a:ln>
+            <a:noFill/>
+          </a:ln>
+        </p:spPr>
+        <p:style>
+          <a:lnRef idx="1">
+            <a:schemeClr val="accent1"/>
+          </a:lnRef>
+          <a:fillRef idx="3">
+            <a:schemeClr val="accent1"/>
+          </a:fillRef>
+          <a:effectRef idx="2">
+            <a:schemeClr val="accent1"/>
+          </a:effectRef>
+          <a:fontRef idx="minor">
+            <a:schemeClr val="lt1"/>
+          </a:fontRef>
+        </p:style>
+        <p:txBody>
+          <a:bodyPr rtlCol="0" anchor="ctr"/>
+          <a:lstStyle/>
+          <a:p>
+            <a:pPr algn="l"/>
+            <a:r>
+              <a:rPr sz="1000" b="1">
+                <a:solidFill>
+                  <a:srgbClr val="FFFFFF"/>
+                </a:solidFill>
+              </a:rPr>
+              <a:t>  PROCESSING PIPELINE</a:t>
+            </a:r>
+          </a:p>
+        </p:txBody>
+      </p:sp>
+      <p:sp>
+        <p:nvSpPr>
+          <p:cNvPr id="6" name="Rectangle 5"/>
+          <p:cNvSpPr/>
+          <p:nvPr/>
+        </p:nvSpPr>
+        <p:spPr>
+          <a:xfrm>
+            <a:off x="164592" y="1938528"/>
             <a:ext cx="804672" cy="384048"/>
           </a:xfrm>
           <a:prstGeom prst="rect">
@@ -3183,7 +3366,7 @@
           </a:fontRef>
         </p:style>
         <p:txBody>
-          <a:bodyPr rtlCol="0" anchor="ctr" wrap="none"/>
+          <a:bodyPr rtlCol="0" anchor="ctr"/>
           <a:lstStyle/>
           <a:p>
             <a:pPr algn="ctr"/>
@@ -3197,7 +3380,7 @@
 </a:t>
             </a:r>
             <a:r>
-              <a:rPr sz="700" b="0">
+              <a:rPr sz="700">
                 <a:solidFill>
                   <a:srgbClr val="CCE8F4"/>
                 </a:solidFill>
@@ -3209,13 +3392,13 @@
       </p:sp>
       <p:sp>
         <p:nvSpPr>
-          <p:cNvPr id="4" name="TextBox 3"/>
+          <p:cNvPr id="7" name="TextBox 6"/>
           <p:cNvSpPr txBox="1"/>
           <p:nvPr/>
         </p:nvSpPr>
         <p:spPr>
           <a:xfrm>
-            <a:off x="987552" y="420624"/>
+            <a:off x="987552" y="2011680"/>
             <a:ext cx="128016" cy="256032"/>
           </a:xfrm>
           <a:prstGeom prst="rect">
@@ -3224,14 +3407,14 @@
           <a:noFill/>
         </p:spPr>
         <p:txBody>
-          <a:bodyPr wrap="square">
+          <a:bodyPr wrap="none">
             <a:spAutoFit/>
           </a:bodyPr>
           <a:lstStyle/>
           <a:p>
             <a:pPr algn="ctr"/>
             <a:r>
-              <a:rPr sz="1400" b="0">
+              <a:rPr sz="1400">
                 <a:solidFill>
                   <a:srgbClr val="2E7D9E"/>
                 </a:solidFill>
@@ -3243,13 +3426,13 @@
       </p:sp>
       <p:sp>
         <p:nvSpPr>
-          <p:cNvPr id="5" name="Rectangle 4"/>
+          <p:cNvPr id="8" name="Rectangle 7"/>
           <p:cNvSpPr/>
           <p:nvPr/>
         </p:nvSpPr>
         <p:spPr>
           <a:xfrm>
-            <a:off x="1133856" y="347472"/>
+            <a:off x="1133856" y="1938528"/>
             <a:ext cx="804672" cy="384048"/>
           </a:xfrm>
           <a:prstGeom prst="rect">
@@ -3277,7 +3460,7 @@
           </a:fontRef>
         </p:style>
         <p:txBody>
-          <a:bodyPr rtlCol="0" anchor="ctr" wrap="none"/>
+          <a:bodyPr rtlCol="0" anchor="ctr"/>
           <a:lstStyle/>
           <a:p>
             <a:pPr algn="ctr"/>
@@ -3291,7 +3474,7 @@
 </a:t>
             </a:r>
             <a:r>
-              <a:rPr sz="700" b="0">
+              <a:rPr sz="700">
                 <a:solidFill>
                   <a:srgbClr val="CCE8F4"/>
                 </a:solidFill>
@@ -3303,13 +3486,13 @@
       </p:sp>
       <p:sp>
         <p:nvSpPr>
-          <p:cNvPr id="6" name="TextBox 5"/>
+          <p:cNvPr id="9" name="TextBox 8"/>
           <p:cNvSpPr txBox="1"/>
           <p:nvPr/>
         </p:nvSpPr>
         <p:spPr>
           <a:xfrm>
-            <a:off x="1956816" y="420624"/>
+            <a:off x="1956816" y="2011680"/>
             <a:ext cx="128016" cy="256032"/>
           </a:xfrm>
           <a:prstGeom prst="rect">
@@ -3318,14 +3501,14 @@
           <a:noFill/>
         </p:spPr>
         <p:txBody>
-          <a:bodyPr wrap="square">
+          <a:bodyPr wrap="none">
             <a:spAutoFit/>
           </a:bodyPr>
           <a:lstStyle/>
           <a:p>
             <a:pPr algn="ctr"/>
             <a:r>
-              <a:rPr sz="1400" b="0">
+              <a:rPr sz="1400">
                 <a:solidFill>
                   <a:srgbClr val="2E7D9E"/>
                 </a:solidFill>
@@ -3337,13 +3520,13 @@
       </p:sp>
       <p:sp>
         <p:nvSpPr>
-          <p:cNvPr id="7" name="Rectangle 6"/>
+          <p:cNvPr id="10" name="Rectangle 9"/>
           <p:cNvSpPr/>
           <p:nvPr/>
         </p:nvSpPr>
         <p:spPr>
           <a:xfrm>
-            <a:off x="2103120" y="347472"/>
+            <a:off x="2103120" y="1938528"/>
             <a:ext cx="804672" cy="384048"/>
           </a:xfrm>
           <a:prstGeom prst="rect">
@@ -3371,7 +3554,7 @@
           </a:fontRef>
         </p:style>
         <p:txBody>
-          <a:bodyPr rtlCol="0" anchor="ctr" wrap="none"/>
+          <a:bodyPr rtlCol="0" anchor="ctr"/>
           <a:lstStyle/>
           <a:p>
             <a:pPr algn="ctr"/>
@@ -3385,7 +3568,7 @@
 </a:t>
             </a:r>
             <a:r>
-              <a:rPr sz="700" b="0">
+              <a:rPr sz="700">
                 <a:solidFill>
                   <a:srgbClr val="CCE8F4"/>
                 </a:solidFill>
@@ -3397,13 +3580,13 @@
       </p:sp>
       <p:sp>
         <p:nvSpPr>
-          <p:cNvPr id="8" name="TextBox 7"/>
+          <p:cNvPr id="11" name="TextBox 10"/>
           <p:cNvSpPr txBox="1"/>
           <p:nvPr/>
         </p:nvSpPr>
         <p:spPr>
           <a:xfrm>
-            <a:off x="2926080" y="420624"/>
+            <a:off x="2926080" y="2011680"/>
             <a:ext cx="128016" cy="256032"/>
           </a:xfrm>
           <a:prstGeom prst="rect">
@@ -3412,14 +3595,14 @@
           <a:noFill/>
         </p:spPr>
         <p:txBody>
-          <a:bodyPr wrap="square">
+          <a:bodyPr wrap="none">
             <a:spAutoFit/>
           </a:bodyPr>
           <a:lstStyle/>
           <a:p>
             <a:pPr algn="ctr"/>
             <a:r>
-              <a:rPr sz="1400" b="0">
+              <a:rPr sz="1400">
                 <a:solidFill>
                   <a:srgbClr val="2E7D9E"/>
                 </a:solidFill>
@@ -3431,13 +3614,13 @@
       </p:sp>
       <p:sp>
         <p:nvSpPr>
-          <p:cNvPr id="9" name="Rectangle 8"/>
+          <p:cNvPr id="12" name="Rectangle 11"/>
           <p:cNvSpPr/>
           <p:nvPr/>
         </p:nvSpPr>
         <p:spPr>
           <a:xfrm>
-            <a:off x="3072384" y="347472"/>
+            <a:off x="3072384" y="1938528"/>
             <a:ext cx="804672" cy="384048"/>
           </a:xfrm>
           <a:prstGeom prst="rect">
@@ -3465,7 +3648,7 @@
           </a:fontRef>
         </p:style>
         <p:txBody>
-          <a:bodyPr rtlCol="0" anchor="ctr" wrap="none"/>
+          <a:bodyPr rtlCol="0" anchor="ctr"/>
           <a:lstStyle/>
           <a:p>
             <a:pPr algn="ctr"/>
@@ -3479,7 +3662,7 @@
 </a:t>
             </a:r>
             <a:r>
-              <a:rPr sz="700" b="0">
+              <a:rPr sz="700">
                 <a:solidFill>
                   <a:srgbClr val="CCE8F4"/>
                 </a:solidFill>
@@ -3491,20 +3674,98 @@
       </p:sp>
       <p:sp>
         <p:nvSpPr>
-          <p:cNvPr id="10" name="Rectangle 9"/>
+          <p:cNvPr id="13" name="TextBox 12"/>
+          <p:cNvSpPr txBox="1"/>
+          <p:nvPr/>
+        </p:nvSpPr>
+        <p:spPr>
+          <a:xfrm>
+            <a:off x="329184" y="2468880"/>
+            <a:ext cx="4078224" cy="1051560"/>
+          </a:xfrm>
+          <a:prstGeom prst="rect">
+            <a:avLst/>
+          </a:prstGeom>
+          <a:noFill/>
+        </p:spPr>
+        <p:txBody>
+          <a:bodyPr wrap="square">
+            <a:spAutoFit/>
+          </a:bodyPr>
+          <a:lstStyle/>
+          <a:p>
+            <a:pPr algn="l"/>
+            <a:r>
+              <a:rPr sz="900">
+                <a:solidFill>
+                  <a:srgbClr val="222222"/>
+                </a:solidFill>
+              </a:rPr>
+              <a:t>•  capture.py  — Pi camera JPEG capture, locked WB &amp; focus</a:t>
+            </a:r>
+          </a:p>
+          <a:p>
+            <a:pPr algn="l"/>
+            <a:r>
+              <a:rPr sz="900">
+                <a:solidFill>
+                  <a:srgbClr val="222222"/>
+                </a:solidFill>
+              </a:rPr>
+              <a:t>•  process.py  — Undistort → detect scale → extract silhouette</a:t>
+            </a:r>
+          </a:p>
+          <a:p>
+            <a:pPr algn="l"/>
+            <a:r>
+              <a:rPr sz="900">
+                <a:solidFill>
+                  <a:srgbClr val="222222"/>
+                </a:solidFill>
+              </a:rPr>
+              <a:t>•  vectorize.py — Binary mask → SVG path via vtracer</a:t>
+            </a:r>
+          </a:p>
+          <a:p>
+            <a:pPr algn="l"/>
+            <a:r>
+              <a:rPr sz="900">
+                <a:solidFill>
+                  <a:srgbClr val="222222"/>
+                </a:solidFill>
+              </a:rPr>
+              <a:t>•  export.py   — Patch SVG to real-world mm for laser cutter</a:t>
+            </a:r>
+          </a:p>
+          <a:p>
+            <a:pPr algn="l"/>
+            <a:r>
+              <a:rPr sz="900">
+                <a:solidFill>
+                  <a:srgbClr val="222222"/>
+                </a:solidFill>
+              </a:rPr>
+              <a:t>•  config.py   — All tunable parameters in one place</a:t>
+            </a:r>
+          </a:p>
+        </p:txBody>
+      </p:sp>
+      <p:sp>
+        <p:nvSpPr>
+          <p:cNvPr id="14" name="Rectangle 13"/>
           <p:cNvSpPr/>
           <p:nvPr/>
         </p:nvSpPr>
         <p:spPr>
           <a:xfrm>
-            <a:off x="164592" y="822960"/>
+            <a:off x="164592" y="3566160"/>
             <a:ext cx="4242816" cy="9144"/>
           </a:xfrm>
           <a:prstGeom prst="rect">
             <a:avLst/>
           </a:prstGeom>
           <a:solidFill>
-            <a:srgbClr val="EEEEEE"/>
+            <a:srgbClr val="DDDDDD"/>
           </a:solidFill>
           <a:ln>
             <a:noFill/>
@@ -3534,91 +3795,14 @@
       </p:sp>
       <p:sp>
         <p:nvSpPr>
-          <p:cNvPr id="11" name="TextBox 10"/>
-          <p:cNvSpPr txBox="1"/>
-          <p:nvPr/>
-        </p:nvSpPr>
-        <p:spPr>
-          <a:xfrm>
-            <a:off x="164592" y="877824"/>
-            <a:ext cx="4242816" cy="822960"/>
-          </a:xfrm>
-          <a:prstGeom prst="rect">
-            <a:avLst/>
-          </a:prstGeom>
-          <a:noFill/>
-        </p:spPr>
-        <p:txBody>
-          <a:bodyPr wrap="square">
-            <a:spAutoFit/>
-          </a:bodyPr>
-          <a:lstStyle/>
-          <a:p>
-            <a:pPr algn="l"/>
-            <a:r>
-              <a:rPr sz="900" b="0">
-                <a:solidFill>
-                  <a:srgbClr val="222222"/>
-                </a:solidFill>
-              </a:rPr>
-              <a:t>Pi camera captures a JPEG → OpenCV undistorts and detects an ArUco marker for real-world scale → tool silhouette is extracted and expanded for foam clearance → vtracer converts the mask to SVG → dimensions are patched to mm for the laser cutter. All parameters live in config.py.</a:t>
-            </a:r>
-          </a:p>
-        </p:txBody>
-      </p:sp>
-      <p:sp>
-        <p:nvSpPr>
-          <p:cNvPr id="12" name="Rectangle 11"/>
+          <p:cNvPr id="15" name="Rectangle 14"/>
           <p:cNvSpPr/>
           <p:nvPr/>
         </p:nvSpPr>
         <p:spPr>
           <a:xfrm>
-            <a:off x="164592" y="1773936"/>
-            <a:ext cx="4242816" cy="9144"/>
-          </a:xfrm>
-          <a:prstGeom prst="rect">
-            <a:avLst/>
-          </a:prstGeom>
-          <a:solidFill>
-            <a:srgbClr val="EEEEEE"/>
-          </a:solidFill>
-          <a:ln>
-            <a:noFill/>
-          </a:ln>
-        </p:spPr>
-        <p:style>
-          <a:lnRef idx="1">
-            <a:schemeClr val="accent1"/>
-          </a:lnRef>
-          <a:fillRef idx="3">
-            <a:schemeClr val="accent1"/>
-          </a:fillRef>
-          <a:effectRef idx="2">
-            <a:schemeClr val="accent1"/>
-          </a:effectRef>
-          <a:fontRef idx="minor">
-            <a:schemeClr val="lt1"/>
-          </a:fontRef>
-        </p:style>
-        <p:txBody>
-          <a:bodyPr rtlCol="0" anchor="ctr"/>
-          <a:lstStyle/>
-          <a:p>
-            <a:pPr algn="ctr"/>
-          </a:p>
-        </p:txBody>
-      </p:sp>
-      <p:sp>
-        <p:nvSpPr>
-          <p:cNvPr id="13" name="Rectangle 12"/>
-          <p:cNvSpPr/>
-          <p:nvPr/>
-        </p:nvSpPr>
-        <p:spPr>
-          <a:xfrm>
-            <a:off x="164592" y="1847088"/>
-            <a:ext cx="691286" cy="201168"/>
+            <a:off x="0" y="3657600"/>
+            <a:ext cx="4572000" cy="256032"/>
           </a:xfrm>
           <a:prstGeom prst="rect">
             <a:avLst/>
@@ -3648,28 +3832,149 @@
           <a:bodyPr rtlCol="0" anchor="ctr"/>
           <a:lstStyle/>
           <a:p>
-            <a:pPr algn="ctr"/>
-            <a:r>
-              <a:rPr sz="800">
+            <a:pPr algn="l"/>
+            <a:r>
+              <a:rPr sz="1000" b="1">
                 <a:solidFill>
                   <a:srgbClr val="FFFFFF"/>
                 </a:solidFill>
               </a:rPr>
-              <a:t>Python 3</a:t>
-            </a:r>
-          </a:p>
-        </p:txBody>
-      </p:sp>
-      <p:sp>
-        <p:nvSpPr>
-          <p:cNvPr id="14" name="Rectangle 13"/>
+              <a:t>  HARDWARE</a:t>
+            </a:r>
+          </a:p>
+        </p:txBody>
+      </p:sp>
+      <p:sp>
+        <p:nvSpPr>
+          <p:cNvPr id="16" name="TextBox 15"/>
+          <p:cNvSpPr txBox="1"/>
+          <p:nvPr/>
+        </p:nvSpPr>
+        <p:spPr>
+          <a:xfrm>
+            <a:off x="329184" y="3931920"/>
+            <a:ext cx="4078224" cy="1051560"/>
+          </a:xfrm>
+          <a:prstGeom prst="rect">
+            <a:avLst/>
+          </a:prstGeom>
+          <a:noFill/>
+        </p:spPr>
+        <p:txBody>
+          <a:bodyPr wrap="square">
+            <a:spAutoFit/>
+          </a:bodyPr>
+          <a:lstStyle/>
+          <a:p>
+            <a:pPr algn="l"/>
+            <a:r>
+              <a:rPr sz="900">
+                <a:solidFill>
+                  <a:srgbClr val="222222"/>
+                </a:solidFill>
+              </a:rPr>
+              <a:t>•  Raspberry Pi</a:t>
+            </a:r>
+          </a:p>
+          <a:p>
+            <a:pPr algn="l"/>
+            <a:r>
+              <a:rPr sz="900">
+                <a:solidFill>
+                  <a:srgbClr val="222222"/>
+                </a:solidFill>
+              </a:rPr>
+              <a:t>•  Pi Camera Module</a:t>
+            </a:r>
+          </a:p>
+          <a:p>
+            <a:pPr algn="l"/>
+            <a:r>
+              <a:rPr sz="900">
+                <a:solidFill>
+                  <a:srgbClr val="222222"/>
+                </a:solidFill>
+              </a:rPr>
+              <a:t>•  Backlit light board (8" × 11.5")</a:t>
+            </a:r>
+          </a:p>
+          <a:p>
+            <a:pPr algn="l"/>
+            <a:r>
+              <a:rPr sz="900">
+                <a:solidFill>
+                  <a:srgbClr val="222222"/>
+                </a:solidFill>
+              </a:rPr>
+              <a:t>•  Printed ArUco marker (20mm reference)</a:t>
+            </a:r>
+          </a:p>
+          <a:p>
+            <a:pPr algn="l"/>
+            <a:r>
+              <a:rPr sz="900">
+                <a:solidFill>
+                  <a:srgbClr val="222222"/>
+                </a:solidFill>
+              </a:rPr>
+              <a:t>•  Laser cutter</a:t>
+            </a:r>
+          </a:p>
+        </p:txBody>
+      </p:sp>
+      <p:sp>
+        <p:nvSpPr>
+          <p:cNvPr id="17" name="Rectangle 16"/>
           <p:cNvSpPr/>
           <p:nvPr/>
         </p:nvSpPr>
         <p:spPr>
           <a:xfrm>
-            <a:off x="929030" y="1847088"/>
-            <a:ext cx="559612" cy="201168"/>
+            <a:off x="164592" y="5029200"/>
+            <a:ext cx="4242816" cy="9144"/>
+          </a:xfrm>
+          <a:prstGeom prst="rect">
+            <a:avLst/>
+          </a:prstGeom>
+          <a:solidFill>
+            <a:srgbClr val="DDDDDD"/>
+          </a:solidFill>
+          <a:ln>
+            <a:noFill/>
+          </a:ln>
+        </p:spPr>
+        <p:style>
+          <a:lnRef idx="1">
+            <a:schemeClr val="accent1"/>
+          </a:lnRef>
+          <a:fillRef idx="3">
+            <a:schemeClr val="accent1"/>
+          </a:fillRef>
+          <a:effectRef idx="2">
+            <a:schemeClr val="accent1"/>
+          </a:effectRef>
+          <a:fontRef idx="minor">
+            <a:schemeClr val="lt1"/>
+          </a:fontRef>
+        </p:style>
+        <p:txBody>
+          <a:bodyPr rtlCol="0" anchor="ctr"/>
+          <a:lstStyle/>
+          <a:p>
+            <a:pPr algn="ctr"/>
+          </a:p>
+        </p:txBody>
+      </p:sp>
+      <p:sp>
+        <p:nvSpPr>
+          <p:cNvPr id="18" name="Rectangle 17"/>
+          <p:cNvSpPr/>
+          <p:nvPr/>
+        </p:nvSpPr>
+        <p:spPr>
+          <a:xfrm>
+            <a:off x="0" y="5120640"/>
+            <a:ext cx="4572000" cy="256032"/>
           </a:xfrm>
           <a:prstGeom prst="rect">
             <a:avLst/>
@@ -3699,28 +4004,149 @@
           <a:bodyPr rtlCol="0" anchor="ctr"/>
           <a:lstStyle/>
           <a:p>
-            <a:pPr algn="ctr"/>
-            <a:r>
-              <a:rPr sz="800">
+            <a:pPr algn="l"/>
+            <a:r>
+              <a:rPr sz="1000" b="1">
                 <a:solidFill>
                   <a:srgbClr val="FFFFFF"/>
                 </a:solidFill>
               </a:rPr>
-              <a:t>OpenCV</a:t>
-            </a:r>
-          </a:p>
-        </p:txBody>
-      </p:sp>
-      <p:sp>
-        <p:nvSpPr>
-          <p:cNvPr id="15" name="Rectangle 14"/>
+              <a:t>  SOFTWARE</a:t>
+            </a:r>
+          </a:p>
+        </p:txBody>
+      </p:sp>
+      <p:sp>
+        <p:nvSpPr>
+          <p:cNvPr id="19" name="TextBox 18"/>
+          <p:cNvSpPr txBox="1"/>
+          <p:nvPr/>
+        </p:nvSpPr>
+        <p:spPr>
+          <a:xfrm>
+            <a:off x="329184" y="5394959"/>
+            <a:ext cx="4078224" cy="1051560"/>
+          </a:xfrm>
+          <a:prstGeom prst="rect">
+            <a:avLst/>
+          </a:prstGeom>
+          <a:noFill/>
+        </p:spPr>
+        <p:txBody>
+          <a:bodyPr wrap="square">
+            <a:spAutoFit/>
+          </a:bodyPr>
+          <a:lstStyle/>
+          <a:p>
+            <a:pPr algn="l"/>
+            <a:r>
+              <a:rPr sz="900">
+                <a:solidFill>
+                  <a:srgbClr val="222222"/>
+                </a:solidFill>
+              </a:rPr>
+              <a:t>•  Python 3</a:t>
+            </a:r>
+          </a:p>
+          <a:p>
+            <a:pPr algn="l"/>
+            <a:r>
+              <a:rPr sz="900">
+                <a:solidFill>
+                  <a:srgbClr val="222222"/>
+                </a:solidFill>
+              </a:rPr>
+              <a:t>•  Picamera2  — camera capture &amp; control</a:t>
+            </a:r>
+          </a:p>
+          <a:p>
+            <a:pPr algn="l"/>
+            <a:r>
+              <a:rPr sz="900">
+                <a:solidFill>
+                  <a:srgbClr val="222222"/>
+                </a:solidFill>
+              </a:rPr>
+              <a:t>•  OpenCV  — distortion correction, ArUco detection, thresholding</a:t>
+            </a:r>
+          </a:p>
+          <a:p>
+            <a:pPr algn="l"/>
+            <a:r>
+              <a:rPr sz="900">
+                <a:solidFill>
+                  <a:srgbClr val="222222"/>
+                </a:solidFill>
+              </a:rPr>
+              <a:t>•  NumPy  — image array math</a:t>
+            </a:r>
+          </a:p>
+          <a:p>
+            <a:pPr algn="l"/>
+            <a:r>
+              <a:rPr sz="900">
+                <a:solidFill>
+                  <a:srgbClr val="222222"/>
+                </a:solidFill>
+              </a:rPr>
+              <a:t>•  vtracer  — bitmap-to-SVG vectorization</a:t>
+            </a:r>
+          </a:p>
+        </p:txBody>
+      </p:sp>
+      <p:sp>
+        <p:nvSpPr>
+          <p:cNvPr id="20" name="Rectangle 19"/>
           <p:cNvSpPr/>
           <p:nvPr/>
         </p:nvSpPr>
         <p:spPr>
           <a:xfrm>
-            <a:off x="1561795" y="1847088"/>
-            <a:ext cx="757123" cy="201168"/>
+            <a:off x="164592" y="6492240"/>
+            <a:ext cx="4242816" cy="9144"/>
+          </a:xfrm>
+          <a:prstGeom prst="rect">
+            <a:avLst/>
+          </a:prstGeom>
+          <a:solidFill>
+            <a:srgbClr val="DDDDDD"/>
+          </a:solidFill>
+          <a:ln>
+            <a:noFill/>
+          </a:ln>
+        </p:spPr>
+        <p:style>
+          <a:lnRef idx="1">
+            <a:schemeClr val="accent1"/>
+          </a:lnRef>
+          <a:fillRef idx="3">
+            <a:schemeClr val="accent1"/>
+          </a:fillRef>
+          <a:effectRef idx="2">
+            <a:schemeClr val="accent1"/>
+          </a:effectRef>
+          <a:fontRef idx="minor">
+            <a:schemeClr val="lt1"/>
+          </a:fontRef>
+        </p:style>
+        <p:txBody>
+          <a:bodyPr rtlCol="0" anchor="ctr"/>
+          <a:lstStyle/>
+          <a:p>
+            <a:pPr algn="ctr"/>
+          </a:p>
+        </p:txBody>
+      </p:sp>
+      <p:sp>
+        <p:nvSpPr>
+          <p:cNvPr id="21" name="Rectangle 20"/>
+          <p:cNvSpPr/>
+          <p:nvPr/>
+        </p:nvSpPr>
+        <p:spPr>
+          <a:xfrm>
+            <a:off x="0" y="6583679"/>
+            <a:ext cx="4572000" cy="256032"/>
           </a:xfrm>
           <a:prstGeom prst="rect">
             <a:avLst/>
@@ -3750,28 +4176,127 @@
           <a:bodyPr rtlCol="0" anchor="ctr"/>
           <a:lstStyle/>
           <a:p>
-            <a:pPr algn="ctr"/>
-            <a:r>
-              <a:rPr sz="800">
+            <a:pPr algn="l"/>
+            <a:r>
+              <a:rPr sz="1000" b="1">
                 <a:solidFill>
                   <a:srgbClr val="FFFFFF"/>
                 </a:solidFill>
               </a:rPr>
-              <a:t>Picamera2</a:t>
-            </a:r>
-          </a:p>
-        </p:txBody>
-      </p:sp>
-      <p:sp>
-        <p:nvSpPr>
-          <p:cNvPr id="16" name="Rectangle 15"/>
+              <a:t>  OUTPUT</a:t>
+            </a:r>
+          </a:p>
+        </p:txBody>
+      </p:sp>
+      <p:sp>
+        <p:nvSpPr>
+          <p:cNvPr id="22" name="TextBox 21"/>
+          <p:cNvSpPr txBox="1"/>
+          <p:nvPr/>
+        </p:nvSpPr>
+        <p:spPr>
+          <a:xfrm>
+            <a:off x="329184" y="6857999"/>
+            <a:ext cx="4078224" cy="649224"/>
+          </a:xfrm>
+          <a:prstGeom prst="rect">
+            <a:avLst/>
+          </a:prstGeom>
+          <a:noFill/>
+        </p:spPr>
+        <p:txBody>
+          <a:bodyPr wrap="square">
+            <a:spAutoFit/>
+          </a:bodyPr>
+          <a:lstStyle/>
+          <a:p>
+            <a:pPr algn="l"/>
+            <a:r>
+              <a:rPr sz="900">
+                <a:solidFill>
+                  <a:srgbClr val="222222"/>
+                </a:solidFill>
+              </a:rPr>
+              <a:t>•  SVG cut file with real-world mm dimensions</a:t>
+            </a:r>
+          </a:p>
+          <a:p>
+            <a:pPr algn="l"/>
+            <a:r>
+              <a:rPr sz="900">
+                <a:solidFill>
+                  <a:srgbClr val="222222"/>
+                </a:solidFill>
+              </a:rPr>
+              <a:t>•  Hairline strokes formatted for laser cutter</a:t>
+            </a:r>
+          </a:p>
+          <a:p>
+            <a:pPr algn="l"/>
+            <a:r>
+              <a:rPr sz="900">
+                <a:solidFill>
+                  <a:srgbClr val="222222"/>
+                </a:solidFill>
+              </a:rPr>
+              <a:t>•  Laser-cut foam shadow insert for toolbox</a:t>
+            </a:r>
+          </a:p>
+        </p:txBody>
+      </p:sp>
+      <p:sp>
+        <p:nvSpPr>
+          <p:cNvPr id="23" name="Rectangle 22"/>
           <p:cNvSpPr/>
           <p:nvPr/>
         </p:nvSpPr>
         <p:spPr>
           <a:xfrm>
-            <a:off x="2392070" y="1847088"/>
-            <a:ext cx="625449" cy="201168"/>
+            <a:off x="164592" y="7552943"/>
+            <a:ext cx="4242816" cy="9144"/>
+          </a:xfrm>
+          <a:prstGeom prst="rect">
+            <a:avLst/>
+          </a:prstGeom>
+          <a:solidFill>
+            <a:srgbClr val="DDDDDD"/>
+          </a:solidFill>
+          <a:ln>
+            <a:noFill/>
+          </a:ln>
+        </p:spPr>
+        <p:style>
+          <a:lnRef idx="1">
+            <a:schemeClr val="accent1"/>
+          </a:lnRef>
+          <a:fillRef idx="3">
+            <a:schemeClr val="accent1"/>
+          </a:fillRef>
+          <a:effectRef idx="2">
+            <a:schemeClr val="accent1"/>
+          </a:effectRef>
+          <a:fontRef idx="minor">
+            <a:schemeClr val="lt1"/>
+          </a:fontRef>
+        </p:style>
+        <p:txBody>
+          <a:bodyPr rtlCol="0" anchor="ctr"/>
+          <a:lstStyle/>
+          <a:p>
+            <a:pPr algn="ctr"/>
+          </a:p>
+        </p:txBody>
+      </p:sp>
+      <p:sp>
+        <p:nvSpPr>
+          <p:cNvPr id="24" name="Rectangle 23"/>
+          <p:cNvSpPr/>
+          <p:nvPr/>
+        </p:nvSpPr>
+        <p:spPr>
+          <a:xfrm>
+            <a:off x="164592" y="7644383"/>
+            <a:ext cx="731520" cy="210312"/>
           </a:xfrm>
           <a:prstGeom prst="rect">
             <a:avLst/>
@@ -3808,21 +4333,21 @@
                   <a:srgbClr val="FFFFFF"/>
                 </a:solidFill>
               </a:rPr>
-              <a:t>vtracer</a:t>
-            </a:r>
-          </a:p>
-        </p:txBody>
-      </p:sp>
-      <p:sp>
-        <p:nvSpPr>
-          <p:cNvPr id="17" name="Rectangle 16"/>
+              <a:t>Python 3</a:t>
+            </a:r>
+          </a:p>
+        </p:txBody>
+      </p:sp>
+      <p:sp>
+        <p:nvSpPr>
+          <p:cNvPr id="25" name="Rectangle 24"/>
           <p:cNvSpPr/>
           <p:nvPr/>
         </p:nvSpPr>
         <p:spPr>
           <a:xfrm>
-            <a:off x="3090671" y="1847088"/>
-            <a:ext cx="954633" cy="201168"/>
+            <a:off x="969264" y="7644383"/>
+            <a:ext cx="594359" cy="210312"/>
           </a:xfrm>
           <a:prstGeom prst="rect">
             <a:avLst/>
@@ -3859,21 +4384,21 @@
                   <a:srgbClr val="FFFFFF"/>
                 </a:solidFill>
               </a:rPr>
-              <a:t>Raspberry Pi</a:t>
-            </a:r>
-          </a:p>
-        </p:txBody>
-      </p:sp>
-      <p:sp>
-        <p:nvSpPr>
-          <p:cNvPr id="18" name="Rectangle 17"/>
+              <a:t>OpenCV</a:t>
+            </a:r>
+          </a:p>
+        </p:txBody>
+      </p:sp>
+      <p:sp>
+        <p:nvSpPr>
+          <p:cNvPr id="26" name="Rectangle 25"/>
           <p:cNvSpPr/>
           <p:nvPr/>
         </p:nvSpPr>
         <p:spPr>
           <a:xfrm>
-            <a:off x="164592" y="2103120"/>
-            <a:ext cx="1020470" cy="201168"/>
+            <a:off x="1636776" y="7644383"/>
+            <a:ext cx="800100" cy="210312"/>
           </a:xfrm>
           <a:prstGeom prst="rect">
             <a:avLst/>
@@ -3910,7 +4435,262 @@
                   <a:srgbClr val="FFFFFF"/>
                 </a:solidFill>
               </a:rPr>
-              <a:t>ArUco Markers</a:t>
+              <a:t>Picamera2</a:t>
+            </a:r>
+          </a:p>
+        </p:txBody>
+      </p:sp>
+      <p:sp>
+        <p:nvSpPr>
+          <p:cNvPr id="27" name="Rectangle 26"/>
+          <p:cNvSpPr/>
+          <p:nvPr/>
+        </p:nvSpPr>
+        <p:spPr>
+          <a:xfrm>
+            <a:off x="2510028" y="7644383"/>
+            <a:ext cx="662940" cy="210312"/>
+          </a:xfrm>
+          <a:prstGeom prst="rect">
+            <a:avLst/>
+          </a:prstGeom>
+          <a:solidFill>
+            <a:srgbClr val="1A3A4A"/>
+          </a:solidFill>
+          <a:ln>
+            <a:noFill/>
+          </a:ln>
+        </p:spPr>
+        <p:style>
+          <a:lnRef idx="1">
+            <a:schemeClr val="accent1"/>
+          </a:lnRef>
+          <a:fillRef idx="3">
+            <a:schemeClr val="accent1"/>
+          </a:fillRef>
+          <a:effectRef idx="2">
+            <a:schemeClr val="accent1"/>
+          </a:effectRef>
+          <a:fontRef idx="minor">
+            <a:schemeClr val="lt1"/>
+          </a:fontRef>
+        </p:style>
+        <p:txBody>
+          <a:bodyPr rtlCol="0" anchor="ctr"/>
+          <a:lstStyle/>
+          <a:p>
+            <a:pPr algn="ctr"/>
+            <a:r>
+              <a:rPr sz="800">
+                <a:solidFill>
+                  <a:srgbClr val="FFFFFF"/>
+                </a:solidFill>
+              </a:rPr>
+              <a:t>vtracer</a:t>
+            </a:r>
+          </a:p>
+        </p:txBody>
+      </p:sp>
+      <p:sp>
+        <p:nvSpPr>
+          <p:cNvPr id="28" name="Rectangle 27"/>
+          <p:cNvSpPr/>
+          <p:nvPr/>
+        </p:nvSpPr>
+        <p:spPr>
+          <a:xfrm>
+            <a:off x="3246120" y="7644383"/>
+            <a:ext cx="525780" cy="210312"/>
+          </a:xfrm>
+          <a:prstGeom prst="rect">
+            <a:avLst/>
+          </a:prstGeom>
+          <a:solidFill>
+            <a:srgbClr val="1A3A4A"/>
+          </a:solidFill>
+          <a:ln>
+            <a:noFill/>
+          </a:ln>
+        </p:spPr>
+        <p:style>
+          <a:lnRef idx="1">
+            <a:schemeClr val="accent1"/>
+          </a:lnRef>
+          <a:fillRef idx="3">
+            <a:schemeClr val="accent1"/>
+          </a:fillRef>
+          <a:effectRef idx="2">
+            <a:schemeClr val="accent1"/>
+          </a:effectRef>
+          <a:fontRef idx="minor">
+            <a:schemeClr val="lt1"/>
+          </a:fontRef>
+        </p:style>
+        <p:txBody>
+          <a:bodyPr rtlCol="0" anchor="ctr"/>
+          <a:lstStyle/>
+          <a:p>
+            <a:pPr algn="ctr"/>
+            <a:r>
+              <a:rPr sz="800">
+                <a:solidFill>
+                  <a:srgbClr val="FFFFFF"/>
+                </a:solidFill>
+              </a:rPr>
+              <a:t>NumPy</a:t>
+            </a:r>
+          </a:p>
+        </p:txBody>
+      </p:sp>
+      <p:sp>
+        <p:nvSpPr>
+          <p:cNvPr id="29" name="Rectangle 28"/>
+          <p:cNvSpPr/>
+          <p:nvPr/>
+        </p:nvSpPr>
+        <p:spPr>
+          <a:xfrm>
+            <a:off x="164592" y="7918703"/>
+            <a:ext cx="1005839" cy="210312"/>
+          </a:xfrm>
+          <a:prstGeom prst="rect">
+            <a:avLst/>
+          </a:prstGeom>
+          <a:solidFill>
+            <a:srgbClr val="1A3A4A"/>
+          </a:solidFill>
+          <a:ln>
+            <a:noFill/>
+          </a:ln>
+        </p:spPr>
+        <p:style>
+          <a:lnRef idx="1">
+            <a:schemeClr val="accent1"/>
+          </a:lnRef>
+          <a:fillRef idx="3">
+            <a:schemeClr val="accent1"/>
+          </a:fillRef>
+          <a:effectRef idx="2">
+            <a:schemeClr val="accent1"/>
+          </a:effectRef>
+          <a:fontRef idx="minor">
+            <a:schemeClr val="lt1"/>
+          </a:fontRef>
+        </p:style>
+        <p:txBody>
+          <a:bodyPr rtlCol="0" anchor="ctr"/>
+          <a:lstStyle/>
+          <a:p>
+            <a:pPr algn="ctr"/>
+            <a:r>
+              <a:rPr sz="800">
+                <a:solidFill>
+                  <a:srgbClr val="FFFFFF"/>
+                </a:solidFill>
+              </a:rPr>
+              <a:t>Raspberry Pi</a:t>
+            </a:r>
+          </a:p>
+        </p:txBody>
+      </p:sp>
+      <p:sp>
+        <p:nvSpPr>
+          <p:cNvPr id="30" name="Rectangle 29"/>
+          <p:cNvSpPr/>
+          <p:nvPr/>
+        </p:nvSpPr>
+        <p:spPr>
+          <a:xfrm>
+            <a:off x="1243584" y="7918703"/>
+            <a:ext cx="525780" cy="210312"/>
+          </a:xfrm>
+          <a:prstGeom prst="rect">
+            <a:avLst/>
+          </a:prstGeom>
+          <a:solidFill>
+            <a:srgbClr val="1A3A4A"/>
+          </a:solidFill>
+          <a:ln>
+            <a:noFill/>
+          </a:ln>
+        </p:spPr>
+        <p:style>
+          <a:lnRef idx="1">
+            <a:schemeClr val="accent1"/>
+          </a:lnRef>
+          <a:fillRef idx="3">
+            <a:schemeClr val="accent1"/>
+          </a:fillRef>
+          <a:effectRef idx="2">
+            <a:schemeClr val="accent1"/>
+          </a:effectRef>
+          <a:fontRef idx="minor">
+            <a:schemeClr val="lt1"/>
+          </a:fontRef>
+        </p:style>
+        <p:txBody>
+          <a:bodyPr rtlCol="0" anchor="ctr"/>
+          <a:lstStyle/>
+          <a:p>
+            <a:pPr algn="ctr"/>
+            <a:r>
+              <a:rPr sz="800">
+                <a:solidFill>
+                  <a:srgbClr val="FFFFFF"/>
+                </a:solidFill>
+              </a:rPr>
+              <a:t>ArUco</a:t>
+            </a:r>
+          </a:p>
+        </p:txBody>
+      </p:sp>
+      <p:sp>
+        <p:nvSpPr>
+          <p:cNvPr id="31" name="Rectangle 30"/>
+          <p:cNvSpPr/>
+          <p:nvPr/>
+        </p:nvSpPr>
+        <p:spPr>
+          <a:xfrm>
+            <a:off x="1842515" y="7918703"/>
+            <a:ext cx="388620" cy="210312"/>
+          </a:xfrm>
+          <a:prstGeom prst="rect">
+            <a:avLst/>
+          </a:prstGeom>
+          <a:solidFill>
+            <a:srgbClr val="1A3A4A"/>
+          </a:solidFill>
+          <a:ln>
+            <a:noFill/>
+          </a:ln>
+        </p:spPr>
+        <p:style>
+          <a:lnRef idx="1">
+            <a:schemeClr val="accent1"/>
+          </a:lnRef>
+          <a:fillRef idx="3">
+            <a:schemeClr val="accent1"/>
+          </a:fillRef>
+          <a:effectRef idx="2">
+            <a:schemeClr val="accent1"/>
+          </a:effectRef>
+          <a:fontRef idx="minor">
+            <a:schemeClr val="lt1"/>
+          </a:fontRef>
+        </p:style>
+        <p:txBody>
+          <a:bodyPr rtlCol="0" anchor="ctr"/>
+          <a:lstStyle/>
+          <a:p>
+            <a:pPr algn="ctr"/>
+            <a:r>
+              <a:rPr sz="800">
+                <a:solidFill>
+                  <a:srgbClr val="FFFFFF"/>
+                </a:solidFill>
+              </a:rPr>
+              <a:t>SVG</a:t>
             </a:r>
           </a:p>
         </p:txBody>

</xml_diff>